<commit_message>
PowerPoint and email: charts, SmartArt, comments, links, levels; mail in older code pages
PowerPoint: charts as tables of their data, SmartArt as a nested list, slide comments as quotes with the author, text hyperlinks kept, titles broken over two lines keep their space (and spaces are collapsed), indented lists with nothing above are re-based so they are not code.
Email: the code pages mails from before UTF-8 use (ISO-8859-2, Windows-1250, Shift_JIS, KS C 5601, ISO-2022-JP...) are registered where a mail is read (they were only known once a CSV or .msg had been converted); an Outlook message without a message code page is read in the ANSI page of its locale.
Samples: slide 6 of powerpoint-review, email-hungarian, email-shiftjis, email-japanese (each fails alone on the previous code).

Co-Authored-By: Claude Sonnet 5.5 <noreply@anthropic.com>
</commit_message>
<xml_diff>
--- a/Dev/Caret.ConverterTests/samples/powerpoint-review.pptx
+++ b/Dev/Caret.ConverterTests/samples/powerpoint-review.pptx
@@ -2,21 +2,133 @@
 <file path=ppt/presentation.xml><?xml version="1.0" encoding="utf-8"?>
 <p:presentation xmlns:p="http://schemas.openxmlformats.org/presentationml/2006/main">
   <p:sldMasterIdLst>
-    <p:sldMasterId xmlns:r="http://schemas.openxmlformats.org/officeDocument/2006/relationships" id="2147483648" r:id="R8de8f0dd156646f8"/>
+    <p:sldMasterId xmlns:r="http://schemas.openxmlformats.org/officeDocument/2006/relationships" id="2147483648" r:id="Rc62b4103cfd345b8"/>
   </p:sldMasterIdLst>
   <p:notesMasterIdLst>
-    <p:notesMasterId xmlns:r="http://schemas.openxmlformats.org/officeDocument/2006/relationships" r:id="Ra801b01dc520432b"/>
+    <p:notesMasterId xmlns:r="http://schemas.openxmlformats.org/officeDocument/2006/relationships" r:id="R724e0d88e9d547d4"/>
   </p:notesMasterIdLst>
   <p:sldIdLst>
-    <p:sldId xmlns:r="http://schemas.openxmlformats.org/officeDocument/2006/relationships" id="256" r:id="Ree285e3b452a4a1c"/>
-    <p:sldId xmlns:r="http://schemas.openxmlformats.org/officeDocument/2006/relationships" id="257" r:id="R9165b527056040b7"/>
-    <p:sldId xmlns:r="http://schemas.openxmlformats.org/officeDocument/2006/relationships" id="258" r:id="Rfeb90ce6a4064e0d"/>
-    <p:sldId xmlns:r="http://schemas.openxmlformats.org/officeDocument/2006/relationships" id="259" r:id="R64cbb730d48f4a2c"/>
-    <p:sldId xmlns:r="http://schemas.openxmlformats.org/officeDocument/2006/relationships" id="260" r:id="R5c8c9cabac124aca"/>
+    <p:sldId xmlns:r="http://schemas.openxmlformats.org/officeDocument/2006/relationships" id="256" r:id="R37f0fc27ebf148c7"/>
+    <p:sldId xmlns:r="http://schemas.openxmlformats.org/officeDocument/2006/relationships" id="257" r:id="R92b3d39ae7ab47a4"/>
+    <p:sldId xmlns:r="http://schemas.openxmlformats.org/officeDocument/2006/relationships" id="258" r:id="Rf518078800b54c18"/>
+    <p:sldId xmlns:r="http://schemas.openxmlformats.org/officeDocument/2006/relationships" id="259" r:id="Rbe08440b5cef47f1"/>
+    <p:sldId xmlns:r="http://schemas.openxmlformats.org/officeDocument/2006/relationships" id="260" r:id="Re33e7e96d9a048d6"/>
+    <p:sldId xmlns:r="http://schemas.openxmlformats.org/officeDocument/2006/relationships" id="261" r:id="R4c119e7d279048f2"/>
   </p:sldIdLst>
   <p:sldSz cx="9144000" cy="6858000" type="screen4x3"/>
   <p:notesSz cx="6858000" cy="9144000"/>
 </p:presentation>
+</file>
+
+<file path=ppt/commentAuthors.xml><?xml version="1.0" encoding="utf-8"?>
+<p:cmAuthorLst xmlns:p="http://schemas.openxmlformats.org/presentationml/2006/main">
+  <p:cmAuthor id="0" name="Reviewer" initials="R" lastIdx="1" clrIdx="0"/>
+</p:cmAuthorLst>
+</file>
+
+<file path=ppt/comments/comment1.xml><?xml version="1.0" encoding="utf-8"?>
+<p:cmLst xmlns:p="http://schemas.openxmlformats.org/presentationml/2006/main">
+  <p:cm authorId="0" dt="2024-05-06T09:00:00" idx="1">
+    <p:pos x="10" y="10"/>
+    <p:text>Check the Q3 figure.</p:text>
+  </p:cm>
+</p:cmLst>
+</file>
+
+<file path=ppt/graphics/colors1.xml><?xml version="1.0" encoding="utf-8"?>
+<dgm:colorsDef xmlns:dgm="http://schemas.openxmlformats.org/drawingml/2006/diagram" uniqueId="urn:test/colors">
+  <dgm:title val=""/>
+  <dgm:desc val=""/>
+  <dgm:catLst/>
+  <dgm:styleLbl name="node0"/>
+</dgm:colorsDef>
+</file>
+
+<file path=ppt/graphics/data1.xml><?xml version="1.0" encoding="utf-8"?>
+<dgm:dataModel xmlns:dgm="http://schemas.openxmlformats.org/drawingml/2006/diagram">
+  <dgm:ptLst>
+    <dgm:pt modelId="{00000000-0000-0000-0000-000000000001}" type="doc">
+      <dgm:prSet/>
+      <dgm:spPr/>
+      <dgm:t>
+        <a:bodyPr xmlns:a="http://schemas.openxmlformats.org/drawingml/2006/main"/>
+        <a:lstStyle xmlns:a="http://schemas.openxmlformats.org/drawingml/2006/main"/>
+        <a:p xmlns:a="http://schemas.openxmlformats.org/drawingml/2006/main">
+          <a:endParaRPr lang="en-US"/>
+        </a:p>
+      </dgm:t>
+    </dgm:pt>
+    <dgm:pt modelId="{00000000-0000-0000-0000-000000000002}">
+      <dgm:prSet/>
+      <dgm:spPr/>
+      <dgm:t>
+        <a:bodyPr xmlns:a="http://schemas.openxmlformats.org/drawingml/2006/main"/>
+        <a:lstStyle xmlns:a="http://schemas.openxmlformats.org/drawingml/2006/main"/>
+        <a:p xmlns:a="http://schemas.openxmlformats.org/drawingml/2006/main">
+          <a:r>
+            <a:t>Plan</a:t>
+          </a:r>
+        </a:p>
+      </dgm:t>
+    </dgm:pt>
+    <dgm:pt modelId="{00000000-0000-0000-0000-000000000003}">
+      <dgm:prSet/>
+      <dgm:spPr/>
+      <dgm:t>
+        <a:bodyPr xmlns:a="http://schemas.openxmlformats.org/drawingml/2006/main"/>
+        <a:lstStyle xmlns:a="http://schemas.openxmlformats.org/drawingml/2006/main"/>
+        <a:p xmlns:a="http://schemas.openxmlformats.org/drawingml/2006/main">
+          <a:r>
+            <a:t>Build</a:t>
+          </a:r>
+        </a:p>
+      </dgm:t>
+    </dgm:pt>
+    <dgm:pt modelId="{00000000-0000-0000-0000-000000000004}">
+      <dgm:prSet/>
+      <dgm:spPr/>
+      <dgm:t>
+        <a:bodyPr xmlns:a="http://schemas.openxmlformats.org/drawingml/2006/main"/>
+        <a:lstStyle xmlns:a="http://schemas.openxmlformats.org/drawingml/2006/main"/>
+        <a:p xmlns:a="http://schemas.openxmlformats.org/drawingml/2006/main">
+          <a:r>
+            <a:t>Test it first</a:t>
+          </a:r>
+        </a:p>
+      </dgm:t>
+    </dgm:pt>
+  </dgm:ptLst>
+  <dgm:cxnLst>
+    <dgm:cxn modelId="{00000000-0000-0000-0000-000000000011}" srcId="{00000000-0000-0000-0000-000000000001}" destId="{00000000-0000-0000-0000-000000000002}" srcOrd="0" destOrd="0"/>
+    <dgm:cxn modelId="{00000000-0000-0000-0000-000000000012}" srcId="{00000000-0000-0000-0000-000000000001}" destId="{00000000-0000-0000-0000-000000000003}" srcOrd="1" destOrd="0"/>
+    <dgm:cxn modelId="{00000000-0000-0000-0000-000000000013}" srcId="{00000000-0000-0000-0000-000000000003}" destId="{00000000-0000-0000-0000-000000000004}" srcOrd="0" destOrd="0"/>
+  </dgm:cxnLst>
+</dgm:dataModel>
+</file>
+
+<file path=ppt/graphics/layout1.xml><?xml version="1.0" encoding="utf-8"?>
+<dgm:layoutDef xmlns:dgm="http://schemas.openxmlformats.org/drawingml/2006/diagram" uniqueId="urn:test/layout">
+  <dgm:title val=""/>
+  <dgm:desc val=""/>
+  <dgm:catLst/>
+  <dgm:sampData/>
+  <dgm:styleData/>
+  <dgm:clrData/>
+  <dgm:layoutNode/>
+</dgm:layoutDef>
+</file>
+
+<file path=ppt/graphics/quickStyle1.xml><?xml version="1.0" encoding="utf-8"?>
+<dgm:styleDef xmlns:dgm="http://schemas.openxmlformats.org/drawingml/2006/diagram" uniqueId="urn:test/style">
+  <dgm:title val=""/>
+  <dgm:desc val=""/>
+  <dgm:catLst/>
+  <dgm:scene3d>
+    <a:camera xmlns:a="http://schemas.openxmlformats.org/drawingml/2006/main" prst="orthographicFront"/>
+    <a:lightRig xmlns:a="http://schemas.openxmlformats.org/drawingml/2006/main" rig="threePt" dir="t"/>
+  </dgm:scene3d>
+  <dgm:styleLbl name="node0"/>
+</dgm:styleDef>
 </file>
 
 <file path=ppt/notesMasters/notesMaster1.xml><?xml version="1.0" encoding="utf-8"?>
@@ -229,9 +341,152 @@
   </p:cSld>
   <p:clrMap bg1="lt1" tx1="dk1" bg2="lt2" tx2="dk2" accent1="accent1" accent2="accent2" accent3="accent3" accent4="accent4" accent5="accent5" accent6="accent6" hlink="hlink" folHlink="folHlink"/>
   <p:sldLayoutIdLst>
-    <p:sldLayoutId xmlns:r="http://schemas.openxmlformats.org/officeDocument/2006/relationships" id="2147483649" r:id="R13c6d14f49dc4055"/>
+    <p:sldLayoutId xmlns:r="http://schemas.openxmlformats.org/officeDocument/2006/relationships" id="2147483649" r:id="R6bb53151cbb84a5a"/>
   </p:sldLayoutIdLst>
 </p:sldMaster>
+</file>
+
+<file path=ppt/slides/charts/chart1.xml><?xml version="1.0" encoding="utf-8"?>
+<c:chartSpace xmlns:c="http://schemas.openxmlformats.org/drawingml/2006/chart">
+  <c:chart>
+    <c:title>
+      <c:tx>
+        <c:rich>
+          <a:bodyPr xmlns:a="http://schemas.openxmlformats.org/drawingml/2006/main"/>
+          <a:lstStyle xmlns:a="http://schemas.openxmlformats.org/drawingml/2006/main"/>
+          <a:p xmlns:a="http://schemas.openxmlformats.org/drawingml/2006/main">
+            <a:r>
+              <a:t>Sales by region</a:t>
+            </a:r>
+          </a:p>
+        </c:rich>
+      </c:tx>
+    </c:title>
+    <c:plotArea>
+      <c:layout/>
+      <c:barChart>
+        <c:barDir val="col"/>
+        <c:grouping val="clustered"/>
+        <c:ser>
+          <c:idx val="0"/>
+          <c:order val="0"/>
+          <c:tx>
+            <c:strRef>
+              <c:f>Sheet1!$B$1</c:f>
+              <c:strCache>
+                <c:ptCount val="1"/>
+                <c:pt idx="0">
+                  <c:v>2023</c:v>
+                </c:pt>
+              </c:strCache>
+            </c:strRef>
+          </c:tx>
+          <c:cat>
+            <c:strRef>
+              <c:f>Sheet1!$A$2:$A$4</c:f>
+              <c:strCache>
+                <c:ptCount val="3"/>
+                <c:pt idx="0">
+                  <c:v>North</c:v>
+                </c:pt>
+                <c:pt idx="1">
+                  <c:v>South</c:v>
+                </c:pt>
+                <c:pt idx="2">
+                  <c:v>East</c:v>
+                </c:pt>
+              </c:strCache>
+            </c:strRef>
+          </c:cat>
+          <c:val>
+            <c:numRef>
+              <c:f>Sheet1!$B$2:$B$4</c:f>
+              <c:numCache>
+                <c:formatCode>General</c:formatCode>
+                <c:ptCount val="3"/>
+                <c:pt idx="0">
+                  <c:v>1200</c:v>
+                </c:pt>
+                <c:pt idx="1">
+                  <c:v>900.5</c:v>
+                </c:pt>
+                <c:pt idx="2">
+                  <c:v>430</c:v>
+                </c:pt>
+              </c:numCache>
+            </c:numRef>
+          </c:val>
+        </c:ser>
+        <c:ser>
+          <c:idx val="1"/>
+          <c:order val="1"/>
+          <c:tx>
+            <c:strRef>
+              <c:f>Sheet1!$C$1</c:f>
+              <c:strCache>
+                <c:ptCount val="1"/>
+                <c:pt idx="0">
+                  <c:v>2024</c:v>
+                </c:pt>
+              </c:strCache>
+            </c:strRef>
+          </c:tx>
+          <c:cat>
+            <c:strRef>
+              <c:f>Sheet1!$A$2:$A$4</c:f>
+              <c:strCache>
+                <c:ptCount val="3"/>
+                <c:pt idx="0">
+                  <c:v>North</c:v>
+                </c:pt>
+                <c:pt idx="1">
+                  <c:v>South</c:v>
+                </c:pt>
+                <c:pt idx="2">
+                  <c:v>East</c:v>
+                </c:pt>
+              </c:strCache>
+            </c:strRef>
+          </c:cat>
+          <c:val>
+            <c:numRef>
+              <c:f>Sheet1!$C$2:$C$4</c:f>
+              <c:numCache>
+                <c:formatCode>General</c:formatCode>
+                <c:ptCount val="3"/>
+                <c:pt idx="0">
+                  <c:v>1350</c:v>
+                </c:pt>
+                <c:pt idx="1">
+                  <c:v>880</c:v>
+                </c:pt>
+                <c:pt idx="2">
+                  <c:v>510.25</c:v>
+                </c:pt>
+              </c:numCache>
+            </c:numRef>
+          </c:val>
+        </c:ser>
+        <c:axId val="111"/>
+        <c:axId val="222"/>
+      </c:barChart>
+      <c:catAx>
+        <c:axId val="111"/>
+        <c:scaling/>
+        <c:delete val="0"/>
+        <c:axPos val="b"/>
+        <c:crossAx val="222"/>
+      </c:catAx>
+      <c:valAx>
+        <c:axId val="222"/>
+        <c:scaling/>
+        <c:delete val="0"/>
+        <c:axPos val="l"/>
+        <c:crossAx val="111"/>
+      </c:valAx>
+    </c:plotArea>
+  </c:chart>
+</c:chartSpace>
 </file>
 
 <file path=ppt/slides/slide1.xml><?xml version="1.0" encoding="utf-8"?>
@@ -586,7 +841,7 @@
           <p:nvPr/>
         </p:nvPicPr>
         <p:blipFill>
-          <a:blip xmlns:r="http://schemas.openxmlformats.org/officeDocument/2006/relationships" xmlns:a="http://schemas.openxmlformats.org/drawingml/2006/main" r:embed="R56a36f2afb7a4fcb"/>
+          <a:blip xmlns:r="http://schemas.openxmlformats.org/officeDocument/2006/relationships" xmlns:a="http://schemas.openxmlformats.org/drawingml/2006/main" r:embed="R6b7ccd47466442e3"/>
           <a:stretch xmlns:a="http://schemas.openxmlformats.org/drawingml/2006/main">
             <a:fillRect/>
           </a:stretch>
@@ -722,6 +977,154 @@
           </a:p>
         </p:txBody>
       </p:sp>
+    </p:spTree>
+  </p:cSld>
+</p:sld>
+</file>
+
+<file path=ppt/slides/slide6.xml><?xml version="1.0" encoding="utf-8"?>
+<p:sld xmlns:p="http://schemas.openxmlformats.org/presentationml/2006/main">
+  <p:cSld>
+    <p:spTree>
+      <p:nvGrpSpPr>
+        <p:cNvPr id="1" name=""/>
+        <p:cNvGrpSpPr/>
+        <p:nvPr/>
+      </p:nvGrpSpPr>
+      <p:grpSpPr>
+        <a:xfrm xmlns:a="http://schemas.openxmlformats.org/drawingml/2006/main"/>
+      </p:grpSpPr>
+      <p:sp>
+        <p:nvSpPr>
+          <p:cNvPr id="2" name="Title"/>
+          <p:cNvSpPr>
+            <a:spLocks xmlns:a="http://schemas.openxmlformats.org/drawingml/2006/main" noGrp="1"/>
+          </p:cNvSpPr>
+          <p:nvPr>
+            <p:ph type="title"/>
+          </p:nvPr>
+        </p:nvSpPr>
+        <p:spPr>
+          <a:xfrm xmlns:a="http://schemas.openxmlformats.org/drawingml/2006/main">
+            <a:off x="0" y="0"/>
+            <a:ext cx="8000000" cy="800000"/>
+          </a:xfrm>
+        </p:spPr>
+        <p:txBody>
+          <a:bodyPr xmlns:a="http://schemas.openxmlformats.org/drawingml/2006/main"/>
+          <a:lstStyle xmlns:a="http://schemas.openxmlformats.org/drawingml/2006/main"/>
+          <a:p xmlns:a="http://schemas.openxmlformats.org/drawingml/2006/main">
+            <a:r>
+              <a:rPr lang="en-US"/>
+              <a:t>Chart and </a:t>
+            </a:r>
+            <a:br/>
+            <a:r>
+              <a:rPr lang="en-US"/>
+              <a:t>diagram</a:t>
+            </a:r>
+          </a:p>
+        </p:txBody>
+      </p:sp>
+      <p:sp>
+        <p:nvSpPr>
+          <p:cNvPr id="3" name="Link"/>
+          <p:cNvSpPr txBox="1">
+            <a:spLocks xmlns:a="http://schemas.openxmlformats.org/drawingml/2006/main" noGrp="1"/>
+          </p:cNvSpPr>
+          <p:nvPr/>
+        </p:nvSpPr>
+        <p:spPr>
+          <a:xfrm xmlns:a="http://schemas.openxmlformats.org/drawingml/2006/main">
+            <a:off x="0" y="1000000"/>
+            <a:ext cx="3500000" cy="600000"/>
+          </a:xfrm>
+        </p:spPr>
+        <p:txBody>
+          <a:bodyPr xmlns:a="http://schemas.openxmlformats.org/drawingml/2006/main"/>
+          <a:lstStyle xmlns:a="http://schemas.openxmlformats.org/drawingml/2006/main"/>
+          <a:p xmlns:a="http://schemas.openxmlformats.org/drawingml/2006/main">
+            <a:r>
+              <a:rPr lang="en-US">
+                <a:hlinkClick xmlns:r="http://schemas.openxmlformats.org/officeDocument/2006/relationships" r:id="Rdd63ba910a12429f"/>
+              </a:rPr>
+              <a:t>Read the plan</a:t>
+            </a:r>
+          </a:p>
+        </p:txBody>
+      </p:sp>
+      <p:sp>
+        <p:nvSpPr>
+          <p:cNvPr id="4" name="Indented"/>
+          <p:cNvSpPr txBox="1">
+            <a:spLocks xmlns:a="http://schemas.openxmlformats.org/drawingml/2006/main" noGrp="1"/>
+          </p:cNvSpPr>
+          <p:nvPr/>
+        </p:nvSpPr>
+        <p:spPr>
+          <a:xfrm xmlns:a="http://schemas.openxmlformats.org/drawingml/2006/main">
+            <a:off x="4000000" y="1000000"/>
+            <a:ext cx="3500000" cy="600000"/>
+          </a:xfrm>
+        </p:spPr>
+        <p:txBody>
+          <a:bodyPr xmlns:a="http://schemas.openxmlformats.org/drawingml/2006/main"/>
+          <a:lstStyle xmlns:a="http://schemas.openxmlformats.org/drawingml/2006/main"/>
+          <a:p xmlns:a="http://schemas.openxmlformats.org/drawingml/2006/main">
+            <a:pPr lvl="1"/>
+            <a:r>
+              <a:rPr lang="en-US"/>
+              <a:t>Child one</a:t>
+            </a:r>
+          </a:p>
+          <a:p xmlns:a="http://schemas.openxmlformats.org/drawingml/2006/main">
+            <a:pPr lvl="1"/>
+            <a:r>
+              <a:rPr lang="en-US"/>
+              <a:t>Child two</a:t>
+            </a:r>
+          </a:p>
+          <a:p xmlns:a="http://schemas.openxmlformats.org/drawingml/2006/main">
+            <a:pPr lvl="2"/>
+            <a:r>
+              <a:rPr lang="en-US"/>
+              <a:t>Grandchild</a:t>
+            </a:r>
+          </a:p>
+        </p:txBody>
+      </p:sp>
+      <p:graphicFrame>
+        <p:nvGraphicFramePr>
+          <p:cNvPr id="5" name="Chart"/>
+          <p:cNvGraphicFramePr/>
+          <p:nvPr/>
+        </p:nvGraphicFramePr>
+        <p:xfrm>
+          <a:off xmlns:a="http://schemas.openxmlformats.org/drawingml/2006/main" x="0" y="2000000"/>
+          <a:ext xmlns:a="http://schemas.openxmlformats.org/drawingml/2006/main" cx="6000000" cy="1800000"/>
+        </p:xfrm>
+        <a:graphic xmlns:a="http://schemas.openxmlformats.org/drawingml/2006/main">
+          <a:graphicData uri="http://schemas.openxmlformats.org/drawingml/2006/chart">
+            <c:chart xmlns:r="http://schemas.openxmlformats.org/officeDocument/2006/relationships" xmlns:c="http://schemas.openxmlformats.org/drawingml/2006/chart" r:id="R0651fc9058e4471c"/>
+          </a:graphicData>
+        </a:graphic>
+      </p:graphicFrame>
+      <p:graphicFrame>
+        <p:nvGraphicFramePr>
+          <p:cNvPr id="6" name="Diagram"/>
+          <p:cNvGraphicFramePr/>
+          <p:nvPr/>
+        </p:nvGraphicFramePr>
+        <p:xfrm>
+          <a:off xmlns:a="http://schemas.openxmlformats.org/drawingml/2006/main" x="0" y="4000000"/>
+          <a:ext xmlns:a="http://schemas.openxmlformats.org/drawingml/2006/main" cx="6000000" cy="1800000"/>
+        </p:xfrm>
+        <a:graphic xmlns:a="http://schemas.openxmlformats.org/drawingml/2006/main">
+          <a:graphicData uri="http://schemas.openxmlformats.org/drawingml/2006/diagram">
+            <dgm:relIds xmlns:r="http://schemas.openxmlformats.org/officeDocument/2006/relationships" xmlns:dgm="http://schemas.openxmlformats.org/drawingml/2006/diagram" r:dm="R6b6253bafcb042c0" r:lo="R3c1dc17bb44e4681" r:qs="R1fd84005f5934666" r:cs="R32bbde31e0ef48e4"/>
+          </a:graphicData>
+        </a:graphic>
+      </p:graphicFrame>
     </p:spTree>
   </p:cSld>
 </p:sld>

</xml_diff>

<commit_message>
PowerPoint: a chart's title is its own, not the first title in the chart part
The titles of the axes are c:title elements too, so a chart without a title of its own (autoTitleDeleted) showed its first axis title in bold above the table. Only c:chart/c:title is read. powerpoint-review gets an untitled chart with an axis title (the sample fails on the previous code).

Co-Authored-By: Claude Sonnet 5.5 <noreply@anthropic.com>
</commit_message>
<xml_diff>
--- a/Dev/Caret.ConverterTests/samples/powerpoint-review.pptx
+++ b/Dev/Caret.ConverterTests/samples/powerpoint-review.pptx
@@ -2,18 +2,18 @@
 <file path=ppt/presentation.xml><?xml version="1.0" encoding="utf-8"?>
 <p:presentation xmlns:p="http://schemas.openxmlformats.org/presentationml/2006/main">
   <p:sldMasterIdLst>
-    <p:sldMasterId xmlns:r="http://schemas.openxmlformats.org/officeDocument/2006/relationships" id="2147483648" r:id="Rc62b4103cfd345b8"/>
+    <p:sldMasterId xmlns:r="http://schemas.openxmlformats.org/officeDocument/2006/relationships" id="2147483648" r:id="R1677969e7c474d4a"/>
   </p:sldMasterIdLst>
   <p:notesMasterIdLst>
-    <p:notesMasterId xmlns:r="http://schemas.openxmlformats.org/officeDocument/2006/relationships" r:id="R724e0d88e9d547d4"/>
+    <p:notesMasterId xmlns:r="http://schemas.openxmlformats.org/officeDocument/2006/relationships" r:id="Rb0e13d4e16f240fc"/>
   </p:notesMasterIdLst>
   <p:sldIdLst>
-    <p:sldId xmlns:r="http://schemas.openxmlformats.org/officeDocument/2006/relationships" id="256" r:id="R37f0fc27ebf148c7"/>
-    <p:sldId xmlns:r="http://schemas.openxmlformats.org/officeDocument/2006/relationships" id="257" r:id="R92b3d39ae7ab47a4"/>
-    <p:sldId xmlns:r="http://schemas.openxmlformats.org/officeDocument/2006/relationships" id="258" r:id="Rf518078800b54c18"/>
-    <p:sldId xmlns:r="http://schemas.openxmlformats.org/officeDocument/2006/relationships" id="259" r:id="Rbe08440b5cef47f1"/>
-    <p:sldId xmlns:r="http://schemas.openxmlformats.org/officeDocument/2006/relationships" id="260" r:id="Re33e7e96d9a048d6"/>
-    <p:sldId xmlns:r="http://schemas.openxmlformats.org/officeDocument/2006/relationships" id="261" r:id="R4c119e7d279048f2"/>
+    <p:sldId xmlns:r="http://schemas.openxmlformats.org/officeDocument/2006/relationships" id="256" r:id="R9738f064f1a94dc4"/>
+    <p:sldId xmlns:r="http://schemas.openxmlformats.org/officeDocument/2006/relationships" id="257" r:id="Ref4840f9a6c646f5"/>
+    <p:sldId xmlns:r="http://schemas.openxmlformats.org/officeDocument/2006/relationships" id="258" r:id="R8f080f08fa894845"/>
+    <p:sldId xmlns:r="http://schemas.openxmlformats.org/officeDocument/2006/relationships" id="259" r:id="R2123936b9643432f"/>
+    <p:sldId xmlns:r="http://schemas.openxmlformats.org/officeDocument/2006/relationships" id="260" r:id="R11f34b3de04b47c2"/>
+    <p:sldId xmlns:r="http://schemas.openxmlformats.org/officeDocument/2006/relationships" id="261" r:id="R9a852bbba82d45ce"/>
   </p:sldIdLst>
   <p:sldSz cx="9144000" cy="6858000" type="screen4x3"/>
   <p:notesSz cx="6858000" cy="9144000"/>
@@ -341,7 +341,7 @@
   </p:cSld>
   <p:clrMap bg1="lt1" tx1="dk1" bg2="lt2" tx2="dk2" accent1="accent1" accent2="accent2" accent3="accent3" accent4="accent4" accent5="accent5" accent6="accent6" hlink="hlink" folHlink="folHlink"/>
   <p:sldLayoutIdLst>
-    <p:sldLayoutId xmlns:r="http://schemas.openxmlformats.org/officeDocument/2006/relationships" id="2147483649" r:id="R6bb53151cbb84a5a"/>
+    <p:sldLayoutId xmlns:r="http://schemas.openxmlformats.org/officeDocument/2006/relationships" id="2147483649" r:id="Ra12674b5652d4a53"/>
   </p:sldLayoutIdLst>
 </p:sldMaster>
 </file>
@@ -482,6 +482,163 @@
         <c:scaling/>
         <c:delete val="0"/>
         <c:axPos val="l"/>
+        <c:title>
+          <c:tx>
+            <c:rich>
+              <a:bodyPr xmlns:a="http://schemas.openxmlformats.org/drawingml/2006/main"/>
+              <a:lstStyle xmlns:a="http://schemas.openxmlformats.org/drawingml/2006/main"/>
+              <a:p xmlns:a="http://schemas.openxmlformats.org/drawingml/2006/main">
+                <a:r>
+                  <a:t>Revenue (USD)</a:t>
+                </a:r>
+              </a:p>
+            </c:rich>
+          </c:tx>
+        </c:title>
+        <c:crossAx val="111"/>
+      </c:valAx>
+    </c:plotArea>
+  </c:chart>
+</c:chartSpace>
+</file>
+
+<file path=ppt/slides/charts/chart2.xml><?xml version="1.0" encoding="utf-8"?>
+<c:chartSpace xmlns:c="http://schemas.openxmlformats.org/drawingml/2006/chart">
+  <c:chart>
+    <c:autoTitleDeleted val="1"/>
+    <c:plotArea>
+      <c:layout/>
+      <c:barChart>
+        <c:barDir val="col"/>
+        <c:grouping val="clustered"/>
+        <c:ser>
+          <c:idx val="0"/>
+          <c:order val="0"/>
+          <c:tx>
+            <c:strRef>
+              <c:f>Sheet1!$B$1</c:f>
+              <c:strCache>
+                <c:ptCount val="1"/>
+                <c:pt idx="0">
+                  <c:v>2023</c:v>
+                </c:pt>
+              </c:strCache>
+            </c:strRef>
+          </c:tx>
+          <c:cat>
+            <c:strRef>
+              <c:f>Sheet1!$A$2:$A$4</c:f>
+              <c:strCache>
+                <c:ptCount val="3"/>
+                <c:pt idx="0">
+                  <c:v>North</c:v>
+                </c:pt>
+                <c:pt idx="1">
+                  <c:v>South</c:v>
+                </c:pt>
+                <c:pt idx="2">
+                  <c:v>East</c:v>
+                </c:pt>
+              </c:strCache>
+            </c:strRef>
+          </c:cat>
+          <c:val>
+            <c:numRef>
+              <c:f>Sheet1!$B$2:$B$4</c:f>
+              <c:numCache>
+                <c:formatCode>General</c:formatCode>
+                <c:ptCount val="3"/>
+                <c:pt idx="0">
+                  <c:v>1200</c:v>
+                </c:pt>
+                <c:pt idx="1">
+                  <c:v>900.5</c:v>
+                </c:pt>
+                <c:pt idx="2">
+                  <c:v>430</c:v>
+                </c:pt>
+              </c:numCache>
+            </c:numRef>
+          </c:val>
+        </c:ser>
+        <c:ser>
+          <c:idx val="1"/>
+          <c:order val="1"/>
+          <c:tx>
+            <c:strRef>
+              <c:f>Sheet1!$C$1</c:f>
+              <c:strCache>
+                <c:ptCount val="1"/>
+                <c:pt idx="0">
+                  <c:v>2024</c:v>
+                </c:pt>
+              </c:strCache>
+            </c:strRef>
+          </c:tx>
+          <c:cat>
+            <c:strRef>
+              <c:f>Sheet1!$A$2:$A$4</c:f>
+              <c:strCache>
+                <c:ptCount val="3"/>
+                <c:pt idx="0">
+                  <c:v>North</c:v>
+                </c:pt>
+                <c:pt idx="1">
+                  <c:v>South</c:v>
+                </c:pt>
+                <c:pt idx="2">
+                  <c:v>East</c:v>
+                </c:pt>
+              </c:strCache>
+            </c:strRef>
+          </c:cat>
+          <c:val>
+            <c:numRef>
+              <c:f>Sheet1!$C$2:$C$4</c:f>
+              <c:numCache>
+                <c:formatCode>General</c:formatCode>
+                <c:ptCount val="3"/>
+                <c:pt idx="0">
+                  <c:v>1350</c:v>
+                </c:pt>
+                <c:pt idx="1">
+                  <c:v>880</c:v>
+                </c:pt>
+                <c:pt idx="2">
+                  <c:v>510.25</c:v>
+                </c:pt>
+              </c:numCache>
+            </c:numRef>
+          </c:val>
+        </c:ser>
+        <c:axId val="111"/>
+        <c:axId val="222"/>
+      </c:barChart>
+      <c:catAx>
+        <c:axId val="111"/>
+        <c:scaling/>
+        <c:delete val="0"/>
+        <c:axPos val="b"/>
+        <c:crossAx val="222"/>
+      </c:catAx>
+      <c:valAx>
+        <c:axId val="222"/>
+        <c:scaling/>
+        <c:delete val="0"/>
+        <c:axPos val="l"/>
+        <c:title>
+          <c:tx>
+            <c:rich>
+              <a:bodyPr xmlns:a="http://schemas.openxmlformats.org/drawingml/2006/main"/>
+              <a:lstStyle xmlns:a="http://schemas.openxmlformats.org/drawingml/2006/main"/>
+              <a:p xmlns:a="http://schemas.openxmlformats.org/drawingml/2006/main">
+                <a:r>
+                  <a:t>Revenue (USD)</a:t>
+                </a:r>
+              </a:p>
+            </c:rich>
+          </c:tx>
+        </c:title>
         <c:crossAx val="111"/>
       </c:valAx>
     </c:plotArea>
@@ -841,7 +998,7 @@
           <p:nvPr/>
         </p:nvPicPr>
         <p:blipFill>
-          <a:blip xmlns:r="http://schemas.openxmlformats.org/officeDocument/2006/relationships" xmlns:a="http://schemas.openxmlformats.org/drawingml/2006/main" r:embed="R6b7ccd47466442e3"/>
+          <a:blip xmlns:r="http://schemas.openxmlformats.org/officeDocument/2006/relationships" xmlns:a="http://schemas.openxmlformats.org/drawingml/2006/main" r:embed="R039e8bcf2a8540c9"/>
           <a:stretch xmlns:a="http://schemas.openxmlformats.org/drawingml/2006/main">
             <a:fillRect/>
           </a:stretch>
@@ -1046,7 +1203,7 @@
           <a:p xmlns:a="http://schemas.openxmlformats.org/drawingml/2006/main">
             <a:r>
               <a:rPr lang="en-US">
-                <a:hlinkClick xmlns:r="http://schemas.openxmlformats.org/officeDocument/2006/relationships" r:id="Rdd63ba910a12429f"/>
+                <a:hlinkClick xmlns:r="http://schemas.openxmlformats.org/officeDocument/2006/relationships" r:id="R410d33b841f64bb3"/>
               </a:rPr>
               <a:t>Read the plan</a:t>
             </a:r>
@@ -1105,7 +1262,23 @@
         </p:xfrm>
         <a:graphic xmlns:a="http://schemas.openxmlformats.org/drawingml/2006/main">
           <a:graphicData uri="http://schemas.openxmlformats.org/drawingml/2006/chart">
-            <c:chart xmlns:r="http://schemas.openxmlformats.org/officeDocument/2006/relationships" xmlns:c="http://schemas.openxmlformats.org/drawingml/2006/chart" r:id="R0651fc9058e4471c"/>
+            <c:chart xmlns:r="http://schemas.openxmlformats.org/officeDocument/2006/relationships" xmlns:c="http://schemas.openxmlformats.org/drawingml/2006/chart" r:id="Rea14b18b14114bd0"/>
+          </a:graphicData>
+        </a:graphic>
+      </p:graphicFrame>
+      <p:graphicFrame>
+        <p:nvGraphicFramePr>
+          <p:cNvPr id="7" name="Chart"/>
+          <p:cNvGraphicFramePr/>
+          <p:nvPr/>
+        </p:nvGraphicFramePr>
+        <p:xfrm>
+          <a:off xmlns:a="http://schemas.openxmlformats.org/drawingml/2006/main" x="0" y="3000000"/>
+          <a:ext xmlns:a="http://schemas.openxmlformats.org/drawingml/2006/main" cx="6000000" cy="1800000"/>
+        </p:xfrm>
+        <a:graphic xmlns:a="http://schemas.openxmlformats.org/drawingml/2006/main">
+          <a:graphicData uri="http://schemas.openxmlformats.org/drawingml/2006/chart">
+            <c:chart xmlns:r="http://schemas.openxmlformats.org/officeDocument/2006/relationships" xmlns:c="http://schemas.openxmlformats.org/drawingml/2006/chart" r:id="Rca82acb8b2b946ec"/>
           </a:graphicData>
         </a:graphic>
       </p:graphicFrame>
@@ -1121,7 +1294,7 @@
         </p:xfrm>
         <a:graphic xmlns:a="http://schemas.openxmlformats.org/drawingml/2006/main">
           <a:graphicData uri="http://schemas.openxmlformats.org/drawingml/2006/diagram">
-            <dgm:relIds xmlns:r="http://schemas.openxmlformats.org/officeDocument/2006/relationships" xmlns:dgm="http://schemas.openxmlformats.org/drawingml/2006/diagram" r:dm="R6b6253bafcb042c0" r:lo="R3c1dc17bb44e4681" r:qs="R1fd84005f5934666" r:cs="R32bbde31e0ef48e4"/>
+            <dgm:relIds xmlns:r="http://schemas.openxmlformats.org/officeDocument/2006/relationships" xmlns:dgm="http://schemas.openxmlformats.org/drawingml/2006/diagram" r:dm="Rcd5ed0c975ed4930" r:lo="R7e78b047517a48de" r:qs="R1ab56774b1134a8c" r:cs="R4bdee313fec342ce"/>
           </a:graphicData>
         </a:graphic>
       </p:graphicFrame>

</xml_diff>